<commit_message>
Checked pigeons brood and asjusted some frontend, like pair accepted and breeder online
</commit_message>
<xml_diff>
--- a/doc/RGZuchtbuchPillars.pptx
+++ b/doc/RGZuchtbuchPillars.pptx
@@ -104,6 +104,11 @@
       </a:defRPr>
     </a:lvl9pPr>
   </p:defaultTextStyle>
+  <p:extLst>
+    <p:ext uri="{EFAFB233-063F-42B5-8137-9DF3F51BA10A}">
+      <p15:sldGuideLst xmlns:p15="http://schemas.microsoft.com/office/powerpoint/2012/main"/>
+    </p:ext>
+  </p:extLst>
 </p:presentation>
 </file>
 
@@ -256,7 +261,7 @@
           <a:p>
             <a:fld id="{0F086804-F2D7-4BD6-BFDF-0DE43FD6B041}" type="datetimeFigureOut">
               <a:rPr lang="de-DE" smtClean="0"/>
-              <a:t>29.07.2025</a:t>
+              <a:t>02.09.2025</a:t>
             </a:fld>
             <a:endParaRPr lang="de-DE"/>
           </a:p>
@@ -456,7 +461,7 @@
           <a:p>
             <a:fld id="{0F086804-F2D7-4BD6-BFDF-0DE43FD6B041}" type="datetimeFigureOut">
               <a:rPr lang="de-DE" smtClean="0"/>
-              <a:t>29.07.2025</a:t>
+              <a:t>02.09.2025</a:t>
             </a:fld>
             <a:endParaRPr lang="de-DE"/>
           </a:p>
@@ -666,7 +671,7 @@
           <a:p>
             <a:fld id="{0F086804-F2D7-4BD6-BFDF-0DE43FD6B041}" type="datetimeFigureOut">
               <a:rPr lang="de-DE" smtClean="0"/>
-              <a:t>29.07.2025</a:t>
+              <a:t>02.09.2025</a:t>
             </a:fld>
             <a:endParaRPr lang="de-DE"/>
           </a:p>
@@ -866,7 +871,7 @@
           <a:p>
             <a:fld id="{0F086804-F2D7-4BD6-BFDF-0DE43FD6B041}" type="datetimeFigureOut">
               <a:rPr lang="de-DE" smtClean="0"/>
-              <a:t>29.07.2025</a:t>
+              <a:t>02.09.2025</a:t>
             </a:fld>
             <a:endParaRPr lang="de-DE"/>
           </a:p>
@@ -1142,7 +1147,7 @@
           <a:p>
             <a:fld id="{0F086804-F2D7-4BD6-BFDF-0DE43FD6B041}" type="datetimeFigureOut">
               <a:rPr lang="de-DE" smtClean="0"/>
-              <a:t>29.07.2025</a:t>
+              <a:t>02.09.2025</a:t>
             </a:fld>
             <a:endParaRPr lang="de-DE"/>
           </a:p>
@@ -1410,7 +1415,7 @@
           <a:p>
             <a:fld id="{0F086804-F2D7-4BD6-BFDF-0DE43FD6B041}" type="datetimeFigureOut">
               <a:rPr lang="de-DE" smtClean="0"/>
-              <a:t>29.07.2025</a:t>
+              <a:t>02.09.2025</a:t>
             </a:fld>
             <a:endParaRPr lang="de-DE"/>
           </a:p>
@@ -1825,7 +1830,7 @@
           <a:p>
             <a:fld id="{0F086804-F2D7-4BD6-BFDF-0DE43FD6B041}" type="datetimeFigureOut">
               <a:rPr lang="de-DE" smtClean="0"/>
-              <a:t>29.07.2025</a:t>
+              <a:t>02.09.2025</a:t>
             </a:fld>
             <a:endParaRPr lang="de-DE"/>
           </a:p>
@@ -1967,7 +1972,7 @@
           <a:p>
             <a:fld id="{0F086804-F2D7-4BD6-BFDF-0DE43FD6B041}" type="datetimeFigureOut">
               <a:rPr lang="de-DE" smtClean="0"/>
-              <a:t>29.07.2025</a:t>
+              <a:t>02.09.2025</a:t>
             </a:fld>
             <a:endParaRPr lang="de-DE"/>
           </a:p>
@@ -2080,7 +2085,7 @@
           <a:p>
             <a:fld id="{0F086804-F2D7-4BD6-BFDF-0DE43FD6B041}" type="datetimeFigureOut">
               <a:rPr lang="de-DE" smtClean="0"/>
-              <a:t>29.07.2025</a:t>
+              <a:t>02.09.2025</a:t>
             </a:fld>
             <a:endParaRPr lang="de-DE"/>
           </a:p>
@@ -2393,7 +2398,7 @@
           <a:p>
             <a:fld id="{0F086804-F2D7-4BD6-BFDF-0DE43FD6B041}" type="datetimeFigureOut">
               <a:rPr lang="de-DE" smtClean="0"/>
-              <a:t>29.07.2025</a:t>
+              <a:t>02.09.2025</a:t>
             </a:fld>
             <a:endParaRPr lang="de-DE"/>
           </a:p>
@@ -2682,7 +2687,7 @@
           <a:p>
             <a:fld id="{0F086804-F2D7-4BD6-BFDF-0DE43FD6B041}" type="datetimeFigureOut">
               <a:rPr lang="de-DE" smtClean="0"/>
-              <a:t>29.07.2025</a:t>
+              <a:t>02.09.2025</a:t>
             </a:fld>
             <a:endParaRPr lang="de-DE"/>
           </a:p>
@@ -2925,7 +2930,7 @@
           <a:p>
             <a:fld id="{0F086804-F2D7-4BD6-BFDF-0DE43FD6B041}" type="datetimeFigureOut">
               <a:rPr lang="de-DE" smtClean="0"/>
-              <a:t>29.07.2025</a:t>
+              <a:t>02.09.2025</a:t>
             </a:fld>
             <a:endParaRPr lang="de-DE"/>
           </a:p>
@@ -3397,9 +3402,8 @@
             <a:r>
               <a:rPr lang="en-NL" sz="2000" dirty="0">
                 <a:solidFill>
-                  <a:schemeClr val="tx1">
-                    <a:lumMod val="85000"/>
-                    <a:lumOff val="15000"/>
+                  <a:schemeClr val="bg2">
+                    <a:lumMod val="25000"/>
                   </a:schemeClr>
                 </a:solidFill>
                 <a:latin typeface="Arial Rounded MT Bold" panose="020F0704030504030204" pitchFamily="34" charset="0"/>
@@ -3408,9 +3412,8 @@
             </a:r>
             <a:endParaRPr lang="de-DE" sz="2000" dirty="0">
               <a:solidFill>
-                <a:schemeClr val="tx1">
-                  <a:lumMod val="85000"/>
-                  <a:lumOff val="15000"/>
+                <a:schemeClr val="bg2">
+                  <a:lumMod val="25000"/>
                 </a:schemeClr>
               </a:solidFill>
               <a:latin typeface="Arial Rounded MT Bold" panose="020F0704030504030204" pitchFamily="34" charset="0"/>
@@ -3473,9 +3476,8 @@
             <a:r>
               <a:rPr lang="en-NL" sz="2000" dirty="0" err="1">
                 <a:solidFill>
-                  <a:schemeClr val="tx1">
-                    <a:lumMod val="85000"/>
-                    <a:lumOff val="15000"/>
+                  <a:schemeClr val="bg2">
+                    <a:lumMod val="25000"/>
                   </a:schemeClr>
                 </a:solidFill>
                 <a:latin typeface="Arial Rounded MT Bold" panose="020F0704030504030204" pitchFamily="34" charset="0"/>
@@ -3484,9 +3486,8 @@
             </a:r>
             <a:endParaRPr lang="de-DE" sz="2000" dirty="0">
               <a:solidFill>
-                <a:schemeClr val="tx1">
-                  <a:lumMod val="85000"/>
-                  <a:lumOff val="15000"/>
+                <a:schemeClr val="bg2">
+                  <a:lumMod val="25000"/>
                 </a:schemeClr>
               </a:solidFill>
               <a:latin typeface="Arial Rounded MT Bold" panose="020F0704030504030204" pitchFamily="34" charset="0"/>
@@ -3549,9 +3550,8 @@
             <a:r>
               <a:rPr lang="en-NL" sz="2000" dirty="0" err="1">
                 <a:solidFill>
-                  <a:schemeClr val="tx1">
-                    <a:lumMod val="85000"/>
-                    <a:lumOff val="15000"/>
+                  <a:schemeClr val="bg2">
+                    <a:lumMod val="25000"/>
                   </a:schemeClr>
                 </a:solidFill>
                 <a:latin typeface="Arial Rounded MT Bold" panose="020F0704030504030204" pitchFamily="34" charset="0"/>
@@ -3560,9 +3560,8 @@
             </a:r>
             <a:endParaRPr lang="de-DE" sz="2000" dirty="0">
               <a:solidFill>
-                <a:schemeClr val="tx1">
-                  <a:lumMod val="85000"/>
-                  <a:lumOff val="15000"/>
+                <a:schemeClr val="bg2">
+                  <a:lumMod val="25000"/>
                 </a:schemeClr>
               </a:solidFill>
               <a:latin typeface="Arial Rounded MT Bold" panose="020F0704030504030204" pitchFamily="34" charset="0"/>
@@ -3623,9 +3622,8 @@
             <a:r>
               <a:rPr lang="en-NL" sz="3600" dirty="0" err="1">
                 <a:solidFill>
-                  <a:schemeClr val="tx1">
-                    <a:lumMod val="85000"/>
-                    <a:lumOff val="15000"/>
+                  <a:schemeClr val="bg2">
+                    <a:lumMod val="25000"/>
                   </a:schemeClr>
                 </a:solidFill>
                 <a:latin typeface="Arial Rounded MT Bold" panose="020F0704030504030204" pitchFamily="34" charset="0"/>
@@ -3634,9 +3632,8 @@
             </a:r>
             <a:endParaRPr lang="de-DE" sz="3600" dirty="0">
               <a:solidFill>
-                <a:schemeClr val="tx1">
-                  <a:lumMod val="85000"/>
-                  <a:lumOff val="15000"/>
+                <a:schemeClr val="bg2">
+                  <a:lumMod val="25000"/>
                 </a:schemeClr>
               </a:solidFill>
               <a:latin typeface="Arial Rounded MT Bold" panose="020F0704030504030204" pitchFamily="34" charset="0"/>
@@ -3695,23 +3692,10 @@
           <a:p>
             <a:pPr algn="ctr"/>
             <a:r>
-              <a:rPr lang="en-NL" sz="1600" dirty="0">
-                <a:solidFill>
-                  <a:schemeClr val="tx1">
-                    <a:lumMod val="85000"/>
-                    <a:lumOff val="15000"/>
-                  </a:schemeClr>
-                </a:solidFill>
-                <a:latin typeface="Arial Rounded MT Bold" panose="020F0704030504030204" pitchFamily="34" charset="0"/>
-              </a:rPr>
-              <a:t>Zu </a:t>
-            </a:r>
-            <a:r>
               <a:rPr lang="en-NL" sz="1600" dirty="0" err="1">
                 <a:solidFill>
-                  <a:schemeClr val="tx1">
-                    <a:lumMod val="85000"/>
-                    <a:lumOff val="15000"/>
+                  <a:schemeClr val="bg2">
+                    <a:lumMod val="25000"/>
                   </a:schemeClr>
                 </a:solidFill>
                 <a:latin typeface="Arial Rounded MT Bold" panose="020F0704030504030204" pitchFamily="34" charset="0"/>
@@ -3720,9 +3704,8 @@
             </a:r>
             <a:endParaRPr lang="de-DE" sz="2000" dirty="0">
               <a:solidFill>
-                <a:schemeClr val="tx1">
-                  <a:lumMod val="85000"/>
-                  <a:lumOff val="15000"/>
+                <a:schemeClr val="bg2">
+                  <a:lumMod val="25000"/>
                 </a:schemeClr>
               </a:solidFill>
               <a:latin typeface="Arial Rounded MT Bold" panose="020F0704030504030204" pitchFamily="34" charset="0"/>
@@ -3781,22 +3764,42 @@
           <a:p>
             <a:pPr algn="ctr"/>
             <a:r>
-              <a:rPr lang="en-NL" sz="2000" dirty="0" err="1">
+              <a:rPr lang="en-NL" sz="1600" dirty="0" err="1">
                 <a:solidFill>
-                  <a:schemeClr val="tx1">
-                    <a:lumMod val="85000"/>
-                    <a:lumOff val="15000"/>
+                  <a:schemeClr val="bg2">
+                    <a:lumMod val="25000"/>
                   </a:schemeClr>
                 </a:solidFill>
                 <a:latin typeface="Arial Rounded MT Bold" panose="020F0704030504030204" pitchFamily="34" charset="0"/>
               </a:rPr>
-              <a:t>Trägt</a:t>
+              <a:t>Erfolgreiches</a:t>
+            </a:r>
+            <a:r>
+              <a:rPr lang="en-NL" sz="1600" dirty="0">
+                <a:solidFill>
+                  <a:schemeClr val="bg2">
+                    <a:lumMod val="25000"/>
+                  </a:schemeClr>
+                </a:solidFill>
+                <a:latin typeface="Arial Rounded MT Bold" panose="020F0704030504030204" pitchFamily="34" charset="0"/>
+              </a:rPr>
+              <a:t> </a:t>
+            </a:r>
+            <a:r>
+              <a:rPr lang="en-NL" sz="1600" dirty="0" err="1">
+                <a:solidFill>
+                  <a:schemeClr val="bg2">
+                    <a:lumMod val="25000"/>
+                  </a:schemeClr>
+                </a:solidFill>
+                <a:latin typeface="Arial Rounded MT Bold" panose="020F0704030504030204" pitchFamily="34" charset="0"/>
+              </a:rPr>
+              <a:t>Züchten</a:t>
             </a:r>
             <a:endParaRPr lang="de-DE" sz="1600" dirty="0">
               <a:solidFill>
-                <a:schemeClr val="tx1">
-                  <a:lumMod val="85000"/>
-                  <a:lumOff val="15000"/>
+                <a:schemeClr val="bg2">
+                  <a:lumMod val="25000"/>
                 </a:schemeClr>
               </a:solidFill>
               <a:latin typeface="Arial Rounded MT Bold" panose="020F0704030504030204" pitchFamily="34" charset="0"/>
@@ -3857,9 +3860,8 @@
             <a:r>
               <a:rPr lang="en-NL" sz="2800" dirty="0" err="1">
                 <a:solidFill>
-                  <a:schemeClr val="tx1">
-                    <a:lumMod val="85000"/>
-                    <a:lumOff val="15000"/>
+                  <a:schemeClr val="bg2">
+                    <a:lumMod val="25000"/>
                   </a:schemeClr>
                 </a:solidFill>
                 <a:latin typeface="Arial Rounded MT Bold" panose="020F0704030504030204" pitchFamily="34" charset="0"/>
@@ -3868,9 +3870,8 @@
             </a:r>
             <a:endParaRPr lang="de-DE" dirty="0">
               <a:solidFill>
-                <a:schemeClr val="tx1">
-                  <a:lumMod val="85000"/>
-                  <a:lumOff val="15000"/>
+                <a:schemeClr val="bg2">
+                  <a:lumMod val="25000"/>
                 </a:schemeClr>
               </a:solidFill>
               <a:latin typeface="Arial Rounded MT Bold" panose="020F0704030504030204" pitchFamily="34" charset="0"/>
@@ -3928,7 +3929,13 @@
           <a:lstStyle/>
           <a:p>
             <a:pPr algn="ctr"/>
-            <a:endParaRPr lang="de-DE"/>
+            <a:endParaRPr lang="de-DE">
+              <a:solidFill>
+                <a:schemeClr val="bg2">
+                  <a:lumMod val="25000"/>
+                </a:schemeClr>
+              </a:solidFill>
+            </a:endParaRPr>
           </a:p>
         </p:txBody>
       </p:sp>

</xml_diff>